<commit_message>
Add IndInnovates deck, update AMD deck, PhysicsEngine 3-phase fix, PDFs
- VajraGrid_IndInnovates_Deck.pptx: Full 8-slide hackathon submission (9.5/10 GPT-4.1 score)
- VajraGrid_IndInnovates_Deck.pdf: PDF export
- VajraGrid_AMD_Slingshot_Deck.pptx: Updated slide 6 with cropped dashboard images
- VajraGrid_AMD_Slingshot_Deck.pdf: PDF export
- PhysicsEngine.ts: Fixed sqrt(3) 3-phase power equation bug

Co-authored-by: Copilot <223556219+Copilot@users.noreply.github.com>
</commit_message>
<xml_diff>
--- a/VajraGrid_AMD_Slingshot_Deck.pptx
+++ b/VajraGrid_AMD_Slingshot_Deck.pptx
@@ -12797,54 +12797,6 @@
           </a:ln>
         </p:spPr>
       </p:pic>
-      <p:pic>
-        <p:nvPicPr>
-          <p:cNvPr id="100" name="Picture 99" descr="dashboard-initial.png"/>
-          <p:cNvPicPr>
-            <a:picLocks noChangeAspect="1"/>
-          </p:cNvPicPr>
-          <p:nvPr/>
-        </p:nvPicPr>
-        <p:blipFill>
-          <a:blip r:embed="rId5"/>
-          <a:stretch>
-            <a:fillRect/>
-          </a:stretch>
-        </p:blipFill>
-        <p:spPr>
-          <a:xfrm>
-            <a:off x="1593283" y="950000"/>
-            <a:ext cx="1413434" cy="3000000"/>
-          </a:xfrm>
-          <a:prstGeom prst="rect">
-            <a:avLst/>
-          </a:prstGeom>
-        </p:spPr>
-      </p:pic>
-      <p:pic>
-        <p:nvPicPr>
-          <p:cNvPr id="101" name="Picture 100" descr="dashboard-running.png"/>
-          <p:cNvPicPr>
-            <a:picLocks noChangeAspect="1"/>
-          </p:cNvPicPr>
-          <p:nvPr/>
-        </p:nvPicPr>
-        <p:blipFill>
-          <a:blip r:embed="rId6"/>
-          <a:stretch>
-            <a:fillRect/>
-          </a:stretch>
-        </p:blipFill>
-        <p:spPr>
-          <a:xfrm>
-            <a:off x="5624810" y="950000"/>
-            <a:ext cx="2350380" cy="3000000"/>
-          </a:xfrm>
-          <a:prstGeom prst="rect">
-            <a:avLst/>
-          </a:prstGeom>
-        </p:spPr>
-      </p:pic>
       <p:sp>
         <p:nvSpPr>
           <p:cNvPr id="96" name="Google Shape;96;p18"/>
@@ -12857,8 +12809,8 @@
         </p:nvSpPr>
         <p:spPr>
           <a:xfrm>
-            <a:off x="311700" y="744575"/>
-            <a:ext cx="8520600" cy="447600"/>
+            <a:off x="365760" y="685800"/>
+            <a:ext cx="2743200" cy="411480"/>
           </a:xfrm>
           <a:prstGeom prst="rect">
             <a:avLst/>
@@ -12897,6 +12849,54 @@
           </a:p>
         </p:txBody>
       </p:sp>
+      <p:pic>
+        <p:nvPicPr>
+          <p:cNvPr id="100" name="Picture 99" descr="cropped-dashboard-initial.png"/>
+          <p:cNvPicPr>
+            <a:picLocks noChangeAspect="1"/>
+          </p:cNvPicPr>
+          <p:nvPr/>
+        </p:nvPicPr>
+        <p:blipFill>
+          <a:blip r:embed="rId7"/>
+          <a:stretch>
+            <a:fillRect/>
+          </a:stretch>
+        </p:blipFill>
+        <p:spPr>
+          <a:xfrm>
+            <a:off x="884908" y="1097280"/>
+            <a:ext cx="2843377" cy="3017520"/>
+          </a:xfrm>
+          <a:prstGeom prst="rect">
+            <a:avLst/>
+          </a:prstGeom>
+        </p:spPr>
+      </p:pic>
+      <p:pic>
+        <p:nvPicPr>
+          <p:cNvPr id="101" name="Picture 100" descr="cropped-dashboard-running.png"/>
+          <p:cNvPicPr>
+            <a:picLocks noChangeAspect="1"/>
+          </p:cNvPicPr>
+          <p:nvPr/>
+        </p:nvPicPr>
+        <p:blipFill>
+          <a:blip r:embed="rId8"/>
+          <a:stretch>
+            <a:fillRect/>
+          </a:stretch>
+        </p:blipFill>
+        <p:spPr>
+          <a:xfrm>
+            <a:off x="3956885" y="1097280"/>
+            <a:ext cx="4302206" cy="3017520"/>
+          </a:xfrm>
+          <a:prstGeom prst="rect">
+            <a:avLst/>
+          </a:prstGeom>
+        </p:spPr>
+      </p:pic>
       <p:sp>
         <p:nvSpPr>
           <p:cNvPr id="102" name="Rounded Rectangle 101"/>
@@ -12905,16 +12905,14 @@
         </p:nvSpPr>
         <p:spPr>
           <a:xfrm>
-            <a:off x="200000" y="4150000"/>
-            <a:ext cx="4100000" cy="350000"/>
+            <a:off x="884908" y="4187952"/>
+            <a:ext cx="2843377" cy="411480"/>
           </a:xfrm>
           <a:prstGeom prst="roundRect">
             <a:avLst/>
           </a:prstGeom>
           <a:solidFill>
-            <a:srgbClr val="16213E">
-              <a:alpha val="85000"/>
-            </a:srgbClr>
+            <a:srgbClr val="2D3A4A"/>
           </a:solidFill>
           <a:ln>
             <a:noFill/>
@@ -12935,24 +12933,25 @@
           </a:fontRef>
         </p:style>
         <p:txBody>
-          <a:bodyPr wrap="square" rtlCol="0" anchor="ctr"/>
+          <a:bodyPr rtlCol="0" anchor="ctr" wrap="square"/>
           <a:lstStyle/>
           <a:p>
             <a:pPr algn="ctr"/>
             <a:r>
               <a:rPr sz="1100" b="1">
                 <a:solidFill>
-                  <a:srgbClr val="ED1C24"/>
+                  <a:srgbClr val="FF4444"/>
                 </a:solidFill>
               </a:rPr>
               <a:t>Dashboard at Startup</a:t>
             </a:r>
           </a:p>
           <a:p>
+            <a:pPr algn="ctr"/>
             <a:r>
               <a:rPr sz="800">
                 <a:solidFill>
-                  <a:srgbClr val="FFFFFF"/>
+                  <a:srgbClr val="CCCCCC"/>
                 </a:solidFill>
               </a:rPr>
               <a:t>Topology map, metric cards, dark SOC theme</a:t>
@@ -12968,16 +12967,14 @@
         </p:nvSpPr>
         <p:spPr>
           <a:xfrm>
-            <a:off x="4700000" y="4150000"/>
-            <a:ext cx="4100000" cy="350000"/>
+            <a:off x="3956885" y="4187952"/>
+            <a:ext cx="4302206" cy="411480"/>
           </a:xfrm>
           <a:prstGeom prst="roundRect">
             <a:avLst/>
           </a:prstGeom>
           <a:solidFill>
-            <a:srgbClr val="16213E">
-              <a:alpha val="85000"/>
-            </a:srgbClr>
+            <a:srgbClr val="2D3A4A"/>
           </a:solidFill>
           <a:ln>
             <a:noFill/>
@@ -12998,24 +12995,25 @@
           </a:fontRef>
         </p:style>
         <p:txBody>
-          <a:bodyPr wrap="square" rtlCol="0" anchor="ctr"/>
+          <a:bodyPr rtlCol="0" anchor="ctr" wrap="square"/>
           <a:lstStyle/>
           <a:p>
             <a:pPr algn="ctr"/>
             <a:r>
               <a:rPr sz="1100" b="1">
                 <a:solidFill>
-                  <a:srgbClr val="ED1C24"/>
+                  <a:srgbClr val="FF4444"/>
                 </a:solidFill>
               </a:rPr>
               <a:t>Live Simulation + Healing</a:t>
             </a:r>
           </a:p>
           <a:p>
+            <a:pPr algn="ctr"/>
             <a:r>
               <a:rPr sz="800">
                 <a:solidFill>
-                  <a:srgbClr val="FFFFFF"/>
+                  <a:srgbClr val="CCCCCC"/>
                 </a:solidFill>
               </a:rPr>
               <a:t>Real-time telemetry, alerts, VajraShield FLISR</a:t>

</xml_diff>